<commit_message>
Link out to XNAT project resources from README and slides
Add a single block of links so a reader can navigate from the tutorial
catalog to the broader XNAT project — main site, download, wiki, and
Read the Docs.

- README Reference section gains a 'XNAT project resources' subsection
  listing xnat.org, xnat.org/download/, wiki.xnat.org, and
  xnat.readthedocs.io/en/stable/.
- slides/build_tutorial_slides.py adds a new 'XNAT project resources'
  closing slide so the deck (now 35 slides) ends on the same set of
  outbound links.
- slides/xnat-tutorials.pptx rebuilt.
- SHA256SUMS rehashed for the touched files.

Co-Authored-By: Claude Opus 4.7 (1M context) <noreply@anthropic.com>
</commit_message>
<xml_diff>
--- a/slides/xnat-tutorials.pptx
+++ b/slides/xnat-tutorials.pptx
@@ -39,6 +39,7 @@
     <p:sldId id="287" r:id="rId39"/>
     <p:sldId id="288" r:id="rId40"/>
     <p:sldId id="289" r:id="rId41"/>
+    <p:sldId id="290" r:id="rId42"/>
   </p:sldIdLst>
   <p:sldSz cx="12191695" cy="6858000" type="screen4x3"/>
   <p:notesSz cx="6858000" cy="9144000"/>
@@ -7954,6 +7955,89 @@
             <a:r>
               <a:rPr sz="2200"/>
               <a:t>REST cheatsheet: tutorials/reference/rest-cheatsheet.md</a:t>
+            </a:r>
+          </a:p>
+        </p:txBody>
+      </p:sp>
+    </p:spTree>
+  </p:cSld>
+  <p:clrMapOvr>
+    <a:masterClrMapping/>
+  </p:clrMapOvr>
+</p:sld>
+</file>
+
+<file path=ppt/slides/slide35.xml><?xml version="1.0" encoding="utf-8"?>
+<p:sld xmlns:a="http://schemas.openxmlformats.org/drawingml/2006/main" xmlns:p="http://schemas.openxmlformats.org/presentationml/2006/main" xmlns:r="http://schemas.openxmlformats.org/officeDocument/2006/relationships">
+  <p:cSld>
+    <p:spTree>
+      <p:nvGrpSpPr>
+        <p:cNvPr id="1" name=""/>
+        <p:cNvGrpSpPr/>
+        <p:nvPr/>
+      </p:nvGrpSpPr>
+      <p:grpSpPr/>
+      <p:sp>
+        <p:nvSpPr>
+          <p:cNvPr id="2" name="Title 1"/>
+          <p:cNvSpPr>
+            <a:spLocks noGrp="1"/>
+          </p:cNvSpPr>
+          <p:nvPr>
+            <p:ph type="title"/>
+          </p:nvPr>
+        </p:nvSpPr>
+        <p:spPr/>
+        <p:txBody>
+          <a:bodyPr/>
+          <a:lstStyle/>
+          <a:p>
+            <a:r>
+              <a:t>XNAT project resources</a:t>
+            </a:r>
+          </a:p>
+        </p:txBody>
+      </p:sp>
+      <p:sp>
+        <p:nvSpPr>
+          <p:cNvPr id="3" name="Content Placeholder 2"/>
+          <p:cNvSpPr>
+            <a:spLocks noGrp="1"/>
+          </p:cNvSpPr>
+          <p:nvPr>
+            <p:ph idx="1"/>
+          </p:nvPr>
+        </p:nvSpPr>
+        <p:spPr/>
+        <p:txBody>
+          <a:bodyPr wrap="square"/>
+          <a:lstStyle/>
+          <a:p>
+            <a:pPr/>
+            <a:r>
+              <a:rPr sz="2200"/>
+              <a:t>xnat.org — project home</a:t>
+            </a:r>
+          </a:p>
+          <a:p>
+            <a:pPr/>
+            <a:r>
+              <a:rPr sz="2200"/>
+              <a:t>xnat.org/download/ — download XNAT</a:t>
+            </a:r>
+          </a:p>
+          <a:p>
+            <a:pPr/>
+            <a:r>
+              <a:rPr sz="2200"/>
+              <a:t>wiki.xnat.org — admin and user wiki</a:t>
+            </a:r>
+          </a:p>
+          <a:p>
+            <a:pPr/>
+            <a:r>
+              <a:rPr sz="2200"/>
+              <a:t>xnat.readthedocs.io/en/stable/ — Read the Docs</a:t>
             </a:r>
           </a:p>
         </p:txBody>

</xml_diff>